<commit_message>
Preparing seeking UX (static for now)
</commit_message>
<xml_diff>
--- a/graphics.pptx
+++ b/graphics.pptx
@@ -6,6 +6,7 @@
   </p:sldMasterIdLst>
   <p:sldIdLst>
     <p:sldId id="256" r:id="rId2"/>
+    <p:sldId id="257" r:id="rId3"/>
   </p:sldIdLst>
   <p:sldSz cx="12192000" cy="6858000"/>
   <p:notesSz cx="6858000" cy="9144000"/>
@@ -259,7 +260,7 @@
           <a:p>
             <a:fld id="{DB06B6BD-112E-43A2-A1C1-0DBA63C63E39}" type="datetimeFigureOut">
               <a:rPr lang="en-US" smtClean="0"/>
-              <a:t>11/19/2023</a:t>
+              <a:t>11/16/2025</a:t>
             </a:fld>
             <a:endParaRPr lang="en-US"/>
           </a:p>
@@ -457,7 +458,7 @@
           <a:p>
             <a:fld id="{DB06B6BD-112E-43A2-A1C1-0DBA63C63E39}" type="datetimeFigureOut">
               <a:rPr lang="en-US" smtClean="0"/>
-              <a:t>11/19/2023</a:t>
+              <a:t>11/16/2025</a:t>
             </a:fld>
             <a:endParaRPr lang="en-US"/>
           </a:p>
@@ -665,7 +666,7 @@
           <a:p>
             <a:fld id="{DB06B6BD-112E-43A2-A1C1-0DBA63C63E39}" type="datetimeFigureOut">
               <a:rPr lang="en-US" smtClean="0"/>
-              <a:t>11/19/2023</a:t>
+              <a:t>11/16/2025</a:t>
             </a:fld>
             <a:endParaRPr lang="en-US"/>
           </a:p>
@@ -863,7 +864,7 @@
           <a:p>
             <a:fld id="{DB06B6BD-112E-43A2-A1C1-0DBA63C63E39}" type="datetimeFigureOut">
               <a:rPr lang="en-US" smtClean="0"/>
-              <a:t>11/19/2023</a:t>
+              <a:t>11/16/2025</a:t>
             </a:fld>
             <a:endParaRPr lang="en-US"/>
           </a:p>
@@ -1138,7 +1139,7 @@
           <a:p>
             <a:fld id="{DB06B6BD-112E-43A2-A1C1-0DBA63C63E39}" type="datetimeFigureOut">
               <a:rPr lang="en-US" smtClean="0"/>
-              <a:t>11/19/2023</a:t>
+              <a:t>11/16/2025</a:t>
             </a:fld>
             <a:endParaRPr lang="en-US"/>
           </a:p>
@@ -1403,7 +1404,7 @@
           <a:p>
             <a:fld id="{DB06B6BD-112E-43A2-A1C1-0DBA63C63E39}" type="datetimeFigureOut">
               <a:rPr lang="en-US" smtClean="0"/>
-              <a:t>11/19/2023</a:t>
+              <a:t>11/16/2025</a:t>
             </a:fld>
             <a:endParaRPr lang="en-US"/>
           </a:p>
@@ -1815,7 +1816,7 @@
           <a:p>
             <a:fld id="{DB06B6BD-112E-43A2-A1C1-0DBA63C63E39}" type="datetimeFigureOut">
               <a:rPr lang="en-US" smtClean="0"/>
-              <a:t>11/19/2023</a:t>
+              <a:t>11/16/2025</a:t>
             </a:fld>
             <a:endParaRPr lang="en-US"/>
           </a:p>
@@ -1956,7 +1957,7 @@
           <a:p>
             <a:fld id="{DB06B6BD-112E-43A2-A1C1-0DBA63C63E39}" type="datetimeFigureOut">
               <a:rPr lang="en-US" smtClean="0"/>
-              <a:t>11/19/2023</a:t>
+              <a:t>11/16/2025</a:t>
             </a:fld>
             <a:endParaRPr lang="en-US"/>
           </a:p>
@@ -2069,7 +2070,7 @@
           <a:p>
             <a:fld id="{DB06B6BD-112E-43A2-A1C1-0DBA63C63E39}" type="datetimeFigureOut">
               <a:rPr lang="en-US" smtClean="0"/>
-              <a:t>11/19/2023</a:t>
+              <a:t>11/16/2025</a:t>
             </a:fld>
             <a:endParaRPr lang="en-US"/>
           </a:p>
@@ -2380,7 +2381,7 @@
           <a:p>
             <a:fld id="{DB06B6BD-112E-43A2-A1C1-0DBA63C63E39}" type="datetimeFigureOut">
               <a:rPr lang="en-US" smtClean="0"/>
-              <a:t>11/19/2023</a:t>
+              <a:t>11/16/2025</a:t>
             </a:fld>
             <a:endParaRPr lang="en-US"/>
           </a:p>
@@ -2668,7 +2669,7 @@
           <a:p>
             <a:fld id="{DB06B6BD-112E-43A2-A1C1-0DBA63C63E39}" type="datetimeFigureOut">
               <a:rPr lang="en-US" smtClean="0"/>
-              <a:t>11/19/2023</a:t>
+              <a:t>11/16/2025</a:t>
             </a:fld>
             <a:endParaRPr lang="en-US"/>
           </a:p>
@@ -2909,7 +2910,7 @@
           <a:p>
             <a:fld id="{DB06B6BD-112E-43A2-A1C1-0DBA63C63E39}" type="datetimeFigureOut">
               <a:rPr lang="en-US" smtClean="0"/>
-              <a:t>11/19/2023</a:t>
+              <a:t>11/16/2025</a:t>
             </a:fld>
             <a:endParaRPr lang="en-US"/>
           </a:p>
@@ -5826,6 +5827,620 @@
 </p:sld>
 </file>
 
+<file path=ppt/slides/slide2.xml><?xml version="1.0" encoding="utf-8"?>
+<p:sld xmlns:a="http://schemas.openxmlformats.org/drawingml/2006/main" xmlns:r="http://schemas.openxmlformats.org/officeDocument/2006/relationships" xmlns:p="http://schemas.openxmlformats.org/presentationml/2006/main">
+  <p:cSld>
+    <p:spTree>
+      <p:nvGrpSpPr>
+        <p:cNvPr id="1" name=""/>
+        <p:cNvGrpSpPr/>
+        <p:nvPr/>
+      </p:nvGrpSpPr>
+      <p:grpSpPr>
+        <a:xfrm>
+          <a:off x="0" y="0"/>
+          <a:ext cx="0" cy="0"/>
+          <a:chOff x="0" y="0"/>
+          <a:chExt cx="0" cy="0"/>
+        </a:xfrm>
+      </p:grpSpPr>
+      <p:sp>
+        <p:nvSpPr>
+          <p:cNvPr id="4" name="Rectangle 3">
+            <a:extLst>
+              <a:ext uri="{FF2B5EF4-FFF2-40B4-BE49-F238E27FC236}">
+                <a16:creationId xmlns:a16="http://schemas.microsoft.com/office/drawing/2014/main" id="{E83ECF96-408E-0329-C1E1-E3C12EDCAC3F}"/>
+              </a:ext>
+            </a:extLst>
+          </p:cNvPr>
+          <p:cNvSpPr/>
+          <p:nvPr/>
+        </p:nvSpPr>
+        <p:spPr>
+          <a:xfrm>
+            <a:off x="2993433" y="1123012"/>
+            <a:ext cx="6085490" cy="3612555"/>
+          </a:xfrm>
+          <a:prstGeom prst="rect">
+            <a:avLst/>
+          </a:prstGeom>
+          <a:solidFill>
+            <a:schemeClr val="tx1"/>
+          </a:solidFill>
+          <a:ln>
+            <a:solidFill>
+              <a:schemeClr val="tx1"/>
+            </a:solidFill>
+          </a:ln>
+        </p:spPr>
+        <p:style>
+          <a:lnRef idx="2">
+            <a:schemeClr val="accent1">
+              <a:shade val="15000"/>
+            </a:schemeClr>
+          </a:lnRef>
+          <a:fillRef idx="1">
+            <a:schemeClr val="accent1"/>
+          </a:fillRef>
+          <a:effectRef idx="0">
+            <a:schemeClr val="accent1"/>
+          </a:effectRef>
+          <a:fontRef idx="minor">
+            <a:schemeClr val="lt1"/>
+          </a:fontRef>
+        </p:style>
+        <p:txBody>
+          <a:bodyPr rtlCol="0" anchor="ctr"/>
+          <a:lstStyle/>
+          <a:p>
+            <a:pPr algn="ctr"/>
+            <a:endParaRPr lang="en-US" dirty="0"/>
+          </a:p>
+        </p:txBody>
+      </p:sp>
+      <p:sp>
+        <p:nvSpPr>
+          <p:cNvPr id="5" name="Rectangle 4">
+            <a:extLst>
+              <a:ext uri="{FF2B5EF4-FFF2-40B4-BE49-F238E27FC236}">
+                <a16:creationId xmlns:a16="http://schemas.microsoft.com/office/drawing/2014/main" id="{B8CB812B-1852-9C31-1A63-916A0071E69E}"/>
+              </a:ext>
+            </a:extLst>
+          </p:cNvPr>
+          <p:cNvSpPr/>
+          <p:nvPr/>
+        </p:nvSpPr>
+        <p:spPr>
+          <a:xfrm>
+            <a:off x="2993433" y="864195"/>
+            <a:ext cx="6085490" cy="258817"/>
+          </a:xfrm>
+          <a:prstGeom prst="rect">
+            <a:avLst/>
+          </a:prstGeom>
+        </p:spPr>
+        <p:style>
+          <a:lnRef idx="2">
+            <a:schemeClr val="accent1">
+              <a:shade val="15000"/>
+            </a:schemeClr>
+          </a:lnRef>
+          <a:fillRef idx="1">
+            <a:schemeClr val="accent1"/>
+          </a:fillRef>
+          <a:effectRef idx="0">
+            <a:schemeClr val="accent1"/>
+          </a:effectRef>
+          <a:fontRef idx="minor">
+            <a:schemeClr val="lt1"/>
+          </a:fontRef>
+        </p:style>
+        <p:txBody>
+          <a:bodyPr rtlCol="0" anchor="ctr"/>
+          <a:lstStyle/>
+          <a:p>
+            <a:r>
+              <a:rPr lang="en-US" sz="1600" dirty="0" err="1"/>
+              <a:t>ImgSort</a:t>
+            </a:r>
+            <a:endParaRPr lang="en-US" sz="1600" dirty="0"/>
+          </a:p>
+        </p:txBody>
+      </p:sp>
+      <p:sp>
+        <p:nvSpPr>
+          <p:cNvPr id="6" name="Rectangle 5">
+            <a:extLst>
+              <a:ext uri="{FF2B5EF4-FFF2-40B4-BE49-F238E27FC236}">
+                <a16:creationId xmlns:a16="http://schemas.microsoft.com/office/drawing/2014/main" id="{462BEAF5-006E-DD45-5B5A-4C0ABA26BBB7}"/>
+              </a:ext>
+            </a:extLst>
+          </p:cNvPr>
+          <p:cNvSpPr/>
+          <p:nvPr/>
+        </p:nvSpPr>
+        <p:spPr>
+          <a:xfrm>
+            <a:off x="3187470" y="1696360"/>
+            <a:ext cx="5697415" cy="342900"/>
+          </a:xfrm>
+          <a:prstGeom prst="rect">
+            <a:avLst/>
+          </a:prstGeom>
+          <a:solidFill>
+            <a:schemeClr val="bg1">
+              <a:lumMod val="65000"/>
+            </a:schemeClr>
+          </a:solidFill>
+          <a:ln>
+            <a:solidFill>
+              <a:schemeClr val="tx1">
+                <a:lumMod val="65000"/>
+                <a:lumOff val="35000"/>
+              </a:schemeClr>
+            </a:solidFill>
+          </a:ln>
+        </p:spPr>
+        <p:style>
+          <a:lnRef idx="2">
+            <a:schemeClr val="accent1">
+              <a:shade val="15000"/>
+            </a:schemeClr>
+          </a:lnRef>
+          <a:fillRef idx="1">
+            <a:schemeClr val="accent1"/>
+          </a:fillRef>
+          <a:effectRef idx="0">
+            <a:schemeClr val="accent1"/>
+          </a:effectRef>
+          <a:fontRef idx="minor">
+            <a:schemeClr val="lt1"/>
+          </a:fontRef>
+        </p:style>
+        <p:txBody>
+          <a:bodyPr rtlCol="0" anchor="ctr"/>
+          <a:lstStyle/>
+          <a:p>
+            <a:pPr algn="ctr"/>
+            <a:endParaRPr lang="en-US"/>
+          </a:p>
+        </p:txBody>
+      </p:sp>
+      <p:sp>
+        <p:nvSpPr>
+          <p:cNvPr id="7" name="Rectangle 6">
+            <a:extLst>
+              <a:ext uri="{FF2B5EF4-FFF2-40B4-BE49-F238E27FC236}">
+                <a16:creationId xmlns:a16="http://schemas.microsoft.com/office/drawing/2014/main" id="{872519CD-D816-3E73-E6D1-2A480829C2A8}"/>
+              </a:ext>
+            </a:extLst>
+          </p:cNvPr>
+          <p:cNvSpPr/>
+          <p:nvPr/>
+        </p:nvSpPr>
+        <p:spPr>
+          <a:xfrm flipH="1">
+            <a:off x="3275135" y="1696360"/>
+            <a:ext cx="74994" cy="342900"/>
+          </a:xfrm>
+          <a:prstGeom prst="rect">
+            <a:avLst/>
+          </a:prstGeom>
+          <a:solidFill>
+            <a:schemeClr val="bg1"/>
+          </a:solidFill>
+          <a:ln>
+            <a:noFill/>
+          </a:ln>
+        </p:spPr>
+        <p:style>
+          <a:lnRef idx="2">
+            <a:schemeClr val="accent1">
+              <a:shade val="15000"/>
+            </a:schemeClr>
+          </a:lnRef>
+          <a:fillRef idx="1">
+            <a:schemeClr val="accent1"/>
+          </a:fillRef>
+          <a:effectRef idx="0">
+            <a:schemeClr val="accent1"/>
+          </a:effectRef>
+          <a:fontRef idx="minor">
+            <a:schemeClr val="lt1"/>
+          </a:fontRef>
+        </p:style>
+        <p:txBody>
+          <a:bodyPr rtlCol="0" anchor="ctr"/>
+          <a:lstStyle/>
+          <a:p>
+            <a:pPr algn="ctr"/>
+            <a:endParaRPr lang="en-US"/>
+          </a:p>
+        </p:txBody>
+      </p:sp>
+      <p:grpSp>
+        <p:nvGrpSpPr>
+          <p:cNvPr id="10" name="Group 9">
+            <a:extLst>
+              <a:ext uri="{FF2B5EF4-FFF2-40B4-BE49-F238E27FC236}">
+                <a16:creationId xmlns:a16="http://schemas.microsoft.com/office/drawing/2014/main" id="{D7948281-C342-A07E-B3BD-80FC504B4B1A}"/>
+              </a:ext>
+            </a:extLst>
+          </p:cNvPr>
+          <p:cNvGrpSpPr/>
+          <p:nvPr/>
+        </p:nvGrpSpPr>
+        <p:grpSpPr>
+          <a:xfrm>
+            <a:off x="3228812" y="1476552"/>
+            <a:ext cx="167640" cy="782516"/>
+            <a:chOff x="1696329" y="2571194"/>
+            <a:chExt cx="167640" cy="782516"/>
+          </a:xfrm>
+        </p:grpSpPr>
+        <p:sp>
+          <p:nvSpPr>
+            <p:cNvPr id="8" name="Isosceles Triangle 7">
+              <a:extLst>
+                <a:ext uri="{FF2B5EF4-FFF2-40B4-BE49-F238E27FC236}">
+                  <a16:creationId xmlns:a16="http://schemas.microsoft.com/office/drawing/2014/main" id="{9A5A1FF6-FDFB-5BC0-07BF-35BE22C2C09A}"/>
+                </a:ext>
+              </a:extLst>
+            </p:cNvPr>
+            <p:cNvSpPr/>
+            <p:nvPr/>
+          </p:nvSpPr>
+          <p:spPr>
+            <a:xfrm>
+              <a:off x="1696329" y="3209192"/>
+              <a:ext cx="167640" cy="144518"/>
+            </a:xfrm>
+            <a:prstGeom prst="triangle">
+              <a:avLst/>
+            </a:prstGeom>
+            <a:solidFill>
+              <a:schemeClr val="bg1">
+                <a:lumMod val="65000"/>
+              </a:schemeClr>
+            </a:solidFill>
+            <a:ln>
+              <a:solidFill>
+                <a:schemeClr val="tx1">
+                  <a:lumMod val="65000"/>
+                  <a:lumOff val="35000"/>
+                </a:schemeClr>
+              </a:solidFill>
+            </a:ln>
+          </p:spPr>
+          <p:style>
+            <a:lnRef idx="2">
+              <a:schemeClr val="accent1">
+                <a:shade val="15000"/>
+              </a:schemeClr>
+            </a:lnRef>
+            <a:fillRef idx="1">
+              <a:schemeClr val="accent1"/>
+            </a:fillRef>
+            <a:effectRef idx="0">
+              <a:schemeClr val="accent1"/>
+            </a:effectRef>
+            <a:fontRef idx="minor">
+              <a:schemeClr val="lt1"/>
+            </a:fontRef>
+          </p:style>
+          <p:txBody>
+            <a:bodyPr rtlCol="0" anchor="ctr"/>
+            <a:lstStyle/>
+            <a:p>
+              <a:pPr algn="ctr"/>
+              <a:endParaRPr lang="en-US"/>
+            </a:p>
+          </p:txBody>
+        </p:sp>
+        <p:sp>
+          <p:nvSpPr>
+            <p:cNvPr id="9" name="Isosceles Triangle 8">
+              <a:extLst>
+                <a:ext uri="{FF2B5EF4-FFF2-40B4-BE49-F238E27FC236}">
+                  <a16:creationId xmlns:a16="http://schemas.microsoft.com/office/drawing/2014/main" id="{29131187-97C5-0632-325E-5685FBA43292}"/>
+                </a:ext>
+              </a:extLst>
+            </p:cNvPr>
+            <p:cNvSpPr/>
+            <p:nvPr/>
+          </p:nvSpPr>
+          <p:spPr>
+            <a:xfrm flipV="1">
+              <a:off x="1696329" y="2571194"/>
+              <a:ext cx="167640" cy="144518"/>
+            </a:xfrm>
+            <a:prstGeom prst="triangle">
+              <a:avLst/>
+            </a:prstGeom>
+            <a:solidFill>
+              <a:schemeClr val="bg1">
+                <a:lumMod val="65000"/>
+              </a:schemeClr>
+            </a:solidFill>
+            <a:ln>
+              <a:solidFill>
+                <a:schemeClr val="tx1">
+                  <a:lumMod val="65000"/>
+                  <a:lumOff val="35000"/>
+                </a:schemeClr>
+              </a:solidFill>
+            </a:ln>
+          </p:spPr>
+          <p:style>
+            <a:lnRef idx="2">
+              <a:schemeClr val="accent1">
+                <a:shade val="15000"/>
+              </a:schemeClr>
+            </a:lnRef>
+            <a:fillRef idx="1">
+              <a:schemeClr val="accent1"/>
+            </a:fillRef>
+            <a:effectRef idx="0">
+              <a:schemeClr val="accent1"/>
+            </a:effectRef>
+            <a:fontRef idx="minor">
+              <a:schemeClr val="lt1"/>
+            </a:fontRef>
+          </p:style>
+          <p:txBody>
+            <a:bodyPr rtlCol="0" anchor="ctr"/>
+            <a:lstStyle/>
+            <a:p>
+              <a:pPr algn="ctr"/>
+              <a:endParaRPr lang="en-US"/>
+            </a:p>
+          </p:txBody>
+        </p:sp>
+      </p:grpSp>
+      <p:sp>
+        <p:nvSpPr>
+          <p:cNvPr id="11" name="TextBox 10">
+            <a:extLst>
+              <a:ext uri="{FF2B5EF4-FFF2-40B4-BE49-F238E27FC236}">
+                <a16:creationId xmlns:a16="http://schemas.microsoft.com/office/drawing/2014/main" id="{FFF94500-A9D4-B966-F2EF-9D0F1D819ED7}"/>
+              </a:ext>
+            </a:extLst>
+          </p:cNvPr>
+          <p:cNvSpPr txBox="1"/>
+          <p:nvPr/>
+        </p:nvSpPr>
+        <p:spPr>
+          <a:xfrm>
+            <a:off x="5250288" y="2728877"/>
+            <a:ext cx="1571777" cy="923330"/>
+          </a:xfrm>
+          <a:prstGeom prst="rect">
+            <a:avLst/>
+          </a:prstGeom>
+          <a:noFill/>
+        </p:spPr>
+        <p:txBody>
+          <a:bodyPr wrap="none" rtlCol="0">
+            <a:spAutoFit/>
+          </a:bodyPr>
+          <a:lstStyle/>
+          <a:p>
+            <a:pPr algn="ctr"/>
+            <a:r>
+              <a:rPr lang="en-US" dirty="0">
+                <a:solidFill>
+                  <a:schemeClr val="bg1"/>
+                </a:solidFill>
+              </a:rPr>
+              <a:t>DCIM9048.JPG</a:t>
+            </a:r>
+          </a:p>
+          <a:p>
+            <a:pPr algn="ctr"/>
+            <a:r>
+              <a:rPr lang="en-US" sz="1000" dirty="0">
+                <a:solidFill>
+                  <a:schemeClr val="bg1"/>
+                </a:solidFill>
+              </a:rPr>
+              <a:t>Mo, 29. Oct 2025, 22:03</a:t>
+            </a:r>
+          </a:p>
+          <a:p>
+            <a:pPr algn="ctr"/>
+            <a:endParaRPr lang="en-US" sz="1000" dirty="0">
+              <a:solidFill>
+                <a:schemeClr val="bg1"/>
+              </a:solidFill>
+            </a:endParaRPr>
+          </a:p>
+          <a:p>
+            <a:pPr algn="ctr"/>
+            <a:r>
+              <a:rPr lang="en-US" sz="800" dirty="0">
+                <a:solidFill>
+                  <a:schemeClr val="tx1">
+                    <a:lumMod val="65000"/>
+                    <a:lumOff val="35000"/>
+                  </a:schemeClr>
+                </a:solidFill>
+              </a:rPr>
+              <a:t>NICON CORPORATION NICON D4</a:t>
+            </a:r>
+          </a:p>
+          <a:p>
+            <a:pPr algn="ctr"/>
+            <a:r>
+              <a:rPr lang="en-US" sz="800" dirty="0">
+                <a:solidFill>
+                  <a:schemeClr val="tx1">
+                    <a:lumMod val="65000"/>
+                    <a:lumOff val="35000"/>
+                  </a:schemeClr>
+                </a:solidFill>
+              </a:rPr>
+              <a:t>70.0-200.0mm f2.8</a:t>
+            </a:r>
+          </a:p>
+        </p:txBody>
+      </p:sp>
+      <p:sp>
+        <p:nvSpPr>
+          <p:cNvPr id="12" name="Rectangle 11">
+            <a:extLst>
+              <a:ext uri="{FF2B5EF4-FFF2-40B4-BE49-F238E27FC236}">
+                <a16:creationId xmlns:a16="http://schemas.microsoft.com/office/drawing/2014/main" id="{11E740C9-929A-C58B-C14C-1D8B070E0C9A}"/>
+              </a:ext>
+            </a:extLst>
+          </p:cNvPr>
+          <p:cNvSpPr/>
+          <p:nvPr/>
+        </p:nvSpPr>
+        <p:spPr>
+          <a:xfrm>
+            <a:off x="8764983" y="864195"/>
+            <a:ext cx="313940" cy="258817"/>
+          </a:xfrm>
+          <a:prstGeom prst="rect">
+            <a:avLst/>
+          </a:prstGeom>
+          <a:solidFill>
+            <a:srgbClr val="FF0000"/>
+          </a:solidFill>
+          <a:ln>
+            <a:solidFill>
+              <a:srgbClr val="C00000"/>
+            </a:solidFill>
+          </a:ln>
+        </p:spPr>
+        <p:style>
+          <a:lnRef idx="2">
+            <a:schemeClr val="accent1">
+              <a:shade val="15000"/>
+            </a:schemeClr>
+          </a:lnRef>
+          <a:fillRef idx="1">
+            <a:schemeClr val="accent1"/>
+          </a:fillRef>
+          <a:effectRef idx="0">
+            <a:schemeClr val="accent1"/>
+          </a:effectRef>
+          <a:fontRef idx="minor">
+            <a:schemeClr val="lt1"/>
+          </a:fontRef>
+        </p:style>
+        <p:txBody>
+          <a:bodyPr rtlCol="0" anchor="ctr"/>
+          <a:lstStyle/>
+          <a:p>
+            <a:pPr algn="ctr"/>
+            <a:r>
+              <a:rPr lang="en-US" sz="1600" dirty="0"/>
+              <a:t>X</a:t>
+            </a:r>
+          </a:p>
+        </p:txBody>
+      </p:sp>
+      <p:sp>
+        <p:nvSpPr>
+          <p:cNvPr id="14" name="TextBox 13">
+            <a:extLst>
+              <a:ext uri="{FF2B5EF4-FFF2-40B4-BE49-F238E27FC236}">
+                <a16:creationId xmlns:a16="http://schemas.microsoft.com/office/drawing/2014/main" id="{D45271DF-B372-50DE-57B4-FCCA0FD288A0}"/>
+              </a:ext>
+            </a:extLst>
+          </p:cNvPr>
+          <p:cNvSpPr txBox="1"/>
+          <p:nvPr/>
+        </p:nvSpPr>
+        <p:spPr>
+          <a:xfrm>
+            <a:off x="2993433" y="1117933"/>
+            <a:ext cx="6095266" cy="307777"/>
+          </a:xfrm>
+          <a:prstGeom prst="rect">
+            <a:avLst/>
+          </a:prstGeom>
+          <a:noFill/>
+        </p:spPr>
+        <p:txBody>
+          <a:bodyPr wrap="square">
+            <a:spAutoFit/>
+          </a:bodyPr>
+          <a:lstStyle/>
+          <a:p>
+            <a:pPr algn="ctr"/>
+            <a:r>
+              <a:rPr lang="en-US" sz="1400" dirty="0">
+                <a:solidFill>
+                  <a:schemeClr val="bg1"/>
+                </a:solidFill>
+              </a:rPr>
+              <a:t>13/139</a:t>
+            </a:r>
+          </a:p>
+        </p:txBody>
+      </p:sp>
+      <p:sp>
+        <p:nvSpPr>
+          <p:cNvPr id="2" name="Rectangle 1">
+            <a:extLst>
+              <a:ext uri="{FF2B5EF4-FFF2-40B4-BE49-F238E27FC236}">
+                <a16:creationId xmlns:a16="http://schemas.microsoft.com/office/drawing/2014/main" id="{54D42A8B-353B-451B-B253-98E4B632506A}"/>
+              </a:ext>
+            </a:extLst>
+          </p:cNvPr>
+          <p:cNvSpPr/>
+          <p:nvPr/>
+        </p:nvSpPr>
+        <p:spPr>
+          <a:xfrm>
+            <a:off x="3125665" y="1476552"/>
+            <a:ext cx="5829300" cy="2849263"/>
+          </a:xfrm>
+          <a:prstGeom prst="rect">
+            <a:avLst/>
+          </a:prstGeom>
+          <a:noFill/>
+        </p:spPr>
+        <p:style>
+          <a:lnRef idx="2">
+            <a:schemeClr val="accent1">
+              <a:shade val="15000"/>
+            </a:schemeClr>
+          </a:lnRef>
+          <a:fillRef idx="1">
+            <a:schemeClr val="accent1"/>
+          </a:fillRef>
+          <a:effectRef idx="0">
+            <a:schemeClr val="accent1"/>
+          </a:effectRef>
+          <a:fontRef idx="minor">
+            <a:schemeClr val="lt1"/>
+          </a:fontRef>
+        </p:style>
+        <p:txBody>
+          <a:bodyPr rtlCol="0" anchor="ctr"/>
+          <a:lstStyle/>
+          <a:p>
+            <a:pPr algn="ctr"/>
+            <a:endParaRPr lang="en-US"/>
+          </a:p>
+        </p:txBody>
+      </p:sp>
+    </p:spTree>
+    <p:extLst>
+      <p:ext uri="{BB962C8B-B14F-4D97-AF65-F5344CB8AC3E}">
+        <p14:creationId xmlns:p14="http://schemas.microsoft.com/office/powerpoint/2010/main" val="606113881"/>
+      </p:ext>
+    </p:extLst>
+  </p:cSld>
+  <p:clrMapOvr>
+    <a:masterClrMapping/>
+  </p:clrMapOvr>
+</p:sld>
+</file>
+
 <file path=ppt/theme/theme1.xml><?xml version="1.0" encoding="utf-8"?>
 <a:theme xmlns:a="http://schemas.openxmlformats.org/drawingml/2006/main" name="Office Theme">
   <a:themeElements>

</xml_diff>